<commit_message>
docs: actualizar contexto y presentacion - Vision AI reemplazada por donativo
</commit_message>
<xml_diff>
--- a/presentacion/SmartValuation_Presentacion.pptx
+++ b/presentacion/SmartValuation_Presentacion.pptx
@@ -3566,7 +3566,7 @@
                   <a:srgbClr val="000000"/>
                 </a:solidFill>
               </a:rPr>
-              <a:t>👁️</a:t>
+              <a:t>📸</a:t>
             </a:r>
             <a:endParaRPr lang="en-US" sz="2400" dirty="0"/>
           </a:p>
@@ -3605,7 +3605,7 @@
                 <a:ea typeface="Arial" pitchFamily="34" charset="-122"/>
                 <a:cs typeface="Arial" pitchFamily="34" charset="-120"/>
               </a:rPr>
-              <a:t>Vision AI</a:t>
+              <a:t>Deteccion por Foto</a:t>
             </a:r>
             <a:endParaRPr lang="en-US" sz="1400" dirty="0"/>
           </a:p>
@@ -3644,7 +3644,7 @@
                 <a:ea typeface="Arial" pitchFamily="34" charset="-122"/>
                 <a:cs typeface="Arial" pitchFamily="34" charset="-120"/>
               </a:rPr>
-              <a:t>Subir foto para detectar producto automaticamente</a:t>
+              <a:t>Proximamente con Vision AI - boton de donativo</a:t>
             </a:r>
             <a:endParaRPr lang="en-US" sz="1100" dirty="0"/>
           </a:p>
@@ -7427,7 +7427,7 @@
                           <a:ea typeface="Arial" pitchFamily="34" charset="-122"/>
                           <a:cs typeface="Arial" pitchFamily="34" charset="-120"/>
                         </a:rPr>
-                        <a:t>Vision AI (foto)</a:t>
+                        <a:t>Deteccion por foto (donativo)</a:t>
                       </a:r>
                       <a:endParaRPr lang="en-US" sz="1100" dirty="0">
                         <a:latin typeface="Arial" charset="0"/>
@@ -10503,203 +10503,6 @@
                           <a:ea typeface="Arial" pitchFamily="34" charset="-122"/>
                           <a:cs typeface="Arial" pitchFamily="34" charset="-120"/>
                         </a:rPr>
-                        <a:t>Vision AI</a:t>
-                      </a:r>
-                      <a:endParaRPr lang="en-US" sz="1200" dirty="0">
-                        <a:latin typeface="Arial" charset="0"/>
-                        <a:ea typeface="Arial" charset="0"/>
-                        <a:cs typeface="Arial" charset="0"/>
-                      </a:endParaRPr>
-                    </a:p>
-                  </a:txBody>
-                  <a:tcPr marL="91440" marR="91440" marT="45720" marB="45720">
-                    <a:lnL w="6350" cap="flat" cmpd="sng" algn="ctr">
-                      <a:solidFill>
-                        <a:srgbClr val="E2E8F0"/>
-                      </a:solidFill>
-                      <a:prstDash val="solid"/>
-                      <a:round/>
-                      <a:headEnd type="none" w="med" len="med"/>
-                      <a:tailEnd type="none" w="med" len="med"/>
-                    </a:lnL>
-                    <a:lnR w="6350" cap="flat" cmpd="sng" algn="ctr">
-                      <a:solidFill>
-                        <a:srgbClr val="E2E8F0"/>
-                      </a:solidFill>
-                      <a:prstDash val="solid"/>
-                      <a:round/>
-                      <a:headEnd type="none" w="med" len="med"/>
-                      <a:tailEnd type="none" w="med" len="med"/>
-                    </a:lnR>
-                    <a:lnT w="6350" cap="flat" cmpd="sng" algn="ctr">
-                      <a:solidFill>
-                        <a:srgbClr val="E2E8F0"/>
-                      </a:solidFill>
-                      <a:prstDash val="solid"/>
-                      <a:round/>
-                      <a:headEnd type="none" w="med" len="med"/>
-                      <a:tailEnd type="none" w="med" len="med"/>
-                    </a:lnT>
-                    <a:lnB w="6350" cap="flat" cmpd="sng" algn="ctr">
-                      <a:solidFill>
-                        <a:srgbClr val="E2E8F0"/>
-                      </a:solidFill>
-                      <a:prstDash val="solid"/>
-                      <a:round/>
-                      <a:headEnd type="none" w="med" len="med"/>
-                      <a:tailEnd type="none" w="med" len="med"/>
-                    </a:lnB>
-                  </a:tcPr>
-                </a:tc>
-                <a:tc>
-                  <a:txBody>
-                    <a:bodyPr/>
-                    <a:lstStyle/>
-                    <a:p>
-                      <a:pPr indent="0" marL="0">
-                        <a:buNone/>
-                      </a:pPr>
-                      <a:r>
-                        <a:rPr lang="en-US" sz="1200" dirty="0">
-                          <a:solidFill>
-                            <a:srgbClr val="1E293B"/>
-                          </a:solidFill>
-                          <a:latin typeface="Arial" pitchFamily="34" charset="0"/>
-                          <a:ea typeface="Arial" pitchFamily="34" charset="-122"/>
-                          <a:cs typeface="Arial" pitchFamily="34" charset="-120"/>
-                        </a:rPr>
-                        <a:t>Google Cloud Vision</a:t>
-                      </a:r>
-                      <a:endParaRPr lang="en-US" sz="1200" dirty="0">
-                        <a:latin typeface="Arial" charset="0"/>
-                        <a:ea typeface="Arial" charset="0"/>
-                        <a:cs typeface="Arial" charset="0"/>
-                      </a:endParaRPr>
-                    </a:p>
-                  </a:txBody>
-                  <a:tcPr marL="91440" marR="91440" marT="45720" marB="45720">
-                    <a:lnL w="6350" cap="flat" cmpd="sng" algn="ctr">
-                      <a:solidFill>
-                        <a:srgbClr val="E2E8F0"/>
-                      </a:solidFill>
-                      <a:prstDash val="solid"/>
-                      <a:round/>
-                      <a:headEnd type="none" w="med" len="med"/>
-                      <a:tailEnd type="none" w="med" len="med"/>
-                    </a:lnL>
-                    <a:lnR w="6350" cap="flat" cmpd="sng" algn="ctr">
-                      <a:solidFill>
-                        <a:srgbClr val="E2E8F0"/>
-                      </a:solidFill>
-                      <a:prstDash val="solid"/>
-                      <a:round/>
-                      <a:headEnd type="none" w="med" len="med"/>
-                      <a:tailEnd type="none" w="med" len="med"/>
-                    </a:lnR>
-                    <a:lnT w="6350" cap="flat" cmpd="sng" algn="ctr">
-                      <a:solidFill>
-                        <a:srgbClr val="E2E8F0"/>
-                      </a:solidFill>
-                      <a:prstDash val="solid"/>
-                      <a:round/>
-                      <a:headEnd type="none" w="med" len="med"/>
-                      <a:tailEnd type="none" w="med" len="med"/>
-                    </a:lnT>
-                    <a:lnB w="6350" cap="flat" cmpd="sng" algn="ctr">
-                      <a:solidFill>
-                        <a:srgbClr val="E2E8F0"/>
-                      </a:solidFill>
-                      <a:prstDash val="solid"/>
-                      <a:round/>
-                      <a:headEnd type="none" w="med" len="med"/>
-                      <a:tailEnd type="none" w="med" len="med"/>
-                    </a:lnB>
-                  </a:tcPr>
-                </a:tc>
-                <a:tc>
-                  <a:txBody>
-                    <a:bodyPr/>
-                    <a:lstStyle/>
-                    <a:p>
-                      <a:pPr indent="0" marL="0">
-                        <a:buNone/>
-                      </a:pPr>
-                      <a:r>
-                        <a:rPr lang="en-US" sz="1200" dirty="0">
-                          <a:solidFill>
-                            <a:srgbClr val="1E293B"/>
-                          </a:solidFill>
-                          <a:latin typeface="Arial" pitchFamily="34" charset="0"/>
-                          <a:ea typeface="Arial" pitchFamily="34" charset="-122"/>
-                          <a:cs typeface="Arial" pitchFamily="34" charset="-120"/>
-                        </a:rPr>
-                        <a:t>Deteccion de fotos</a:t>
-                      </a:r>
-                      <a:endParaRPr lang="en-US" sz="1200" dirty="0">
-                        <a:latin typeface="Arial" charset="0"/>
-                        <a:ea typeface="Arial" charset="0"/>
-                        <a:cs typeface="Arial" charset="0"/>
-                      </a:endParaRPr>
-                    </a:p>
-                  </a:txBody>
-                  <a:tcPr marL="91440" marR="91440" marT="45720" marB="45720">
-                    <a:lnL w="6350" cap="flat" cmpd="sng" algn="ctr">
-                      <a:solidFill>
-                        <a:srgbClr val="E2E8F0"/>
-                      </a:solidFill>
-                      <a:prstDash val="solid"/>
-                      <a:round/>
-                      <a:headEnd type="none" w="med" len="med"/>
-                      <a:tailEnd type="none" w="med" len="med"/>
-                    </a:lnL>
-                    <a:lnR w="6350" cap="flat" cmpd="sng" algn="ctr">
-                      <a:solidFill>
-                        <a:srgbClr val="E2E8F0"/>
-                      </a:solidFill>
-                      <a:prstDash val="solid"/>
-                      <a:round/>
-                      <a:headEnd type="none" w="med" len="med"/>
-                      <a:tailEnd type="none" w="med" len="med"/>
-                    </a:lnR>
-                    <a:lnT w="6350" cap="flat" cmpd="sng" algn="ctr">
-                      <a:solidFill>
-                        <a:srgbClr val="E2E8F0"/>
-                      </a:solidFill>
-                      <a:prstDash val="solid"/>
-                      <a:round/>
-                      <a:headEnd type="none" w="med" len="med"/>
-                      <a:tailEnd type="none" w="med" len="med"/>
-                    </a:lnT>
-                    <a:lnB w="6350" cap="flat" cmpd="sng" algn="ctr">
-                      <a:solidFill>
-                        <a:srgbClr val="E2E8F0"/>
-                      </a:solidFill>
-                      <a:prstDash val="solid"/>
-                      <a:round/>
-                      <a:headEnd type="none" w="med" len="med"/>
-                      <a:tailEnd type="none" w="med" len="med"/>
-                    </a:lnB>
-                  </a:tcPr>
-                </a:tc>
-              </a:tr>
-              <a:tr h="411480">
-                <a:tc>
-                  <a:txBody>
-                    <a:bodyPr/>
-                    <a:lstStyle/>
-                    <a:p>
-                      <a:pPr indent="0" marL="0">
-                        <a:buNone/>
-                      </a:pPr>
-                      <a:r>
-                        <a:rPr lang="en-US" sz="1200" dirty="0">
-                          <a:solidFill>
-                            <a:srgbClr val="1E293B"/>
-                          </a:solidFill>
-                          <a:latin typeface="Arial" pitchFamily="34" charset="0"/>
-                          <a:ea typeface="Arial" pitchFamily="34" charset="-122"/>
-                          <a:cs typeface="Arial" pitchFamily="34" charset="-120"/>
-                        </a:rPr>
                         <a:t>Graficas</a:t>
                       </a:r>
                       <a:endParaRPr lang="en-US" sz="1200" dirty="0">
@@ -14505,7 +14308,7 @@
                 <a:ea typeface="Courier New" pitchFamily="34" charset="-122"/>
                 <a:cs typeface="Courier New" pitchFamily="34" charset="-120"/>
               </a:rPr>
-              <a:t>Motor de Precios → IA Descripcion → Chatbot → Vision AI → Analisis
+              <a:t>Motor de Precios → IA Descripcion → Chatbot → Analisis
 </a:t>
             </a:r>
             <a:pPr indent="0" marL="0">

</xml_diff>